<commit_message>
Report and deck: live-site usage for The Place; two-run Studio cost comparison
Co-Authored-By: Claude Opus 5.5 <noreply@anthropic.com>
</commit_message>
<xml_diff>
--- a/docs/Through_Line_final_deck.pptx
+++ b/docs/Through_Line_final_deck.pptx
@@ -1092,7 +1092,7 @@
           <a:lstStyle/>
           <a:p>
             <a:r>
-              <a:t>Keystone's whole journey cost 6 cents in model fees: 33 agent runs, 339,000 input and 52,000 output tokens. Web search adds at most 18 cents. A typical year for one organization is about $1, and the most anyone can spend while staying within the allowances is about $8. That's $10,000 a year in AI fees for 10,000 organizations. The main cost control is limiting how often each organization can use the agents.</a:t>
+              <a:t>Keystone's whole journey cost 6 cents in model fees: 33 agent runs, 339,000 input and 52,000 output tokens. Web search adds at most 18 cents. A typical year for one organization is about $1, and the most anyone can spend while staying within the allowances is about $8. That's $10,000 a year in AI fees for 10,000 organizations. Two independent Studio runs (Keystone locally, The Place on the live site) cost 4.9 and 5.7 cents, so onboarding cost is predictable. The main cost control is limiting how often each organization can use the agents.</a:t>
             </a:r>
           </a:p>
         </p:txBody>
@@ -9437,7 +9437,7 @@
                 </a:solidFill>
                 <a:latin typeface="Segoe UI"/>
               </a:rPr>
-              <a:t>Keystone's whole journey, upper bound ($0.06 tokens + ≤ $0.18 web search)</a:t>
+              <a:t>Keystone, whole journey: 6¢ tokens + ≤ 18¢ search</a:t>
             </a:r>
           </a:p>
         </p:txBody>
@@ -9571,11 +9571,11 @@
           <a:p>
             <a:pPr algn="l">
               <a:spcAft>
-                <a:spcPts val="400"/>
+                <a:spcPts val="300"/>
               </a:spcAft>
             </a:pPr>
             <a:r>
-              <a:rPr sz="1300" b="1" i="0">
+              <a:rPr sz="1200" b="1" i="0">
                 <a:solidFill>
                   <a:srgbClr val="2B2B2B"/>
                 </a:solidFill>
@@ -9587,7 +9587,7 @@
           <a:p>
             <a:pPr algn="l">
               <a:spcAft>
-                <a:spcPts val="400"/>
+                <a:spcPts val="300"/>
               </a:spcAft>
             </a:pPr>
             <a:r>
@@ -9600,7 +9600,7 @@
               <a:t>100 orgs  </a:t>
             </a:r>
             <a:r>
-              <a:rPr sz="1300" b="0" i="0">
+              <a:rPr sz="1200" b="0" i="0">
                 <a:solidFill>
                   <a:srgbClr val="2B2B2B"/>
                 </a:solidFill>
@@ -9612,7 +9612,7 @@
           <a:p>
             <a:pPr algn="l">
               <a:spcAft>
-                <a:spcPts val="400"/>
+                <a:spcPts val="300"/>
               </a:spcAft>
             </a:pPr>
             <a:r>
@@ -9625,7 +9625,7 @@
               <a:t>10,000 orgs  </a:t>
             </a:r>
             <a:r>
-              <a:rPr sz="1300" b="0" i="0">
+              <a:rPr sz="1200" b="0" i="0">
                 <a:solidFill>
                   <a:srgbClr val="2B2B2B"/>
                 </a:solidFill>
@@ -9637,11 +9637,11 @@
           <a:p>
             <a:pPr algn="l">
               <a:spcAft>
-                <a:spcPts val="400"/>
+                <a:spcPts val="300"/>
               </a:spcAft>
             </a:pPr>
             <a:r>
-              <a:rPr sz="1300" b="1" i="0">
+              <a:rPr sz="1200" b="1" i="0">
                 <a:solidFill>
                   <a:srgbClr val="2B2B2B"/>
                 </a:solidFill>
@@ -9650,13 +9650,38 @@
               <a:t>Worst case </a:t>
             </a:r>
             <a:r>
-              <a:rPr sz="1300" b="0" i="0">
+              <a:rPr sz="1200" b="0" i="0">
                 <a:solidFill>
                   <a:srgbClr val="2B2B2B"/>
                 </a:solidFill>
                 <a:latin typeface="Segoe UI"/>
               </a:rPr>
               <a:t>≈ $8 per org</a:t>
+            </a:r>
+          </a:p>
+          <a:p>
+            <a:pPr algn="l">
+              <a:spcAft>
+                <a:spcPts val="300"/>
+              </a:spcAft>
+            </a:pPr>
+            <a:r>
+              <a:rPr sz="1200" b="1" i="0">
+                <a:solidFill>
+                  <a:srgbClr val="2B2B2B"/>
+                </a:solidFill>
+                <a:latin typeface="Segoe UI"/>
+              </a:rPr>
+              <a:t>Studio, 2 real runs: </a:t>
+            </a:r>
+            <a:r>
+              <a:rPr sz="1200" b="0" i="0">
+                <a:solidFill>
+                  <a:srgbClr val="2B2B2B"/>
+                </a:solidFill>
+                <a:latin typeface="Segoe UI"/>
+              </a:rPr>
+              <a:t>4.9¢ and 5.7¢</a:t>
             </a:r>
           </a:p>
         </p:txBody>

</xml_diff>